<commit_message>
Changed workflow and instructions to always convert both down- and upcast.
</commit_message>
<xml_diff>
--- a/DOC/SBE_CTD_Toolkit.pptx
+++ b/DOC/SBE_CTD_Toolkit.pptx
@@ -5,23 +5,22 @@
     <p:sldMasterId id="2147483648" r:id="rId1"/>
   </p:sldMasterIdLst>
   <p:notesMasterIdLst>
-    <p:notesMasterId r:id="rId16"/>
+    <p:notesMasterId r:id="rId15"/>
   </p:notesMasterIdLst>
   <p:sldIdLst>
     <p:sldId id="256" r:id="rId2"/>
     <p:sldId id="257" r:id="rId3"/>
     <p:sldId id="258" r:id="rId4"/>
     <p:sldId id="259" r:id="rId5"/>
-    <p:sldId id="260" r:id="rId6"/>
-    <p:sldId id="261" r:id="rId7"/>
-    <p:sldId id="262" r:id="rId8"/>
-    <p:sldId id="263" r:id="rId9"/>
-    <p:sldId id="264" r:id="rId10"/>
-    <p:sldId id="265" r:id="rId11"/>
-    <p:sldId id="266" r:id="rId12"/>
-    <p:sldId id="267" r:id="rId13"/>
-    <p:sldId id="268" r:id="rId14"/>
-    <p:sldId id="269" r:id="rId15"/>
+    <p:sldId id="261" r:id="rId6"/>
+    <p:sldId id="262" r:id="rId7"/>
+    <p:sldId id="263" r:id="rId8"/>
+    <p:sldId id="264" r:id="rId9"/>
+    <p:sldId id="265" r:id="rId10"/>
+    <p:sldId id="266" r:id="rId11"/>
+    <p:sldId id="267" r:id="rId12"/>
+    <p:sldId id="268" r:id="rId13"/>
+    <p:sldId id="269" r:id="rId14"/>
   </p:sldIdLst>
   <p:sldSz cx="9144000" cy="5143500" type="screen16x9"/>
   <p:notesSz cx="5143500" cy="9144000"/>
@@ -130,7 +129,6 @@
             <p14:sldId id="257"/>
             <p14:sldId id="258"/>
             <p14:sldId id="259"/>
-            <p14:sldId id="260"/>
           </p14:sldIdLst>
         </p14:section>
         <p14:section name="Conductivity alignment" id="{CDDBB791-C6F2-D269-20DD-6EC82F673178}">
@@ -421,7 +419,7 @@
           <a:p>
             <a:r>
               <a:rPr lang="en-US" dirty="0"/>
-              <a:t>Source: training PDF pages 344 and 345. Viewing hysteresis in DO-T space helps separate it from hydrographic features.</a:t>
+              <a:t>Source: training PDF page 347. The training activity advances oxygen voltage 2, 4, and 6 seconds and plots T vs oxygen.</a:t>
             </a:r>
           </a:p>
         </p:txBody>
@@ -506,10 +504,7 @@
           <a:bodyPr/>
           <a:lstStyle/>
           <a:p>
-            <a:r>
-              <a:rPr lang="en-US" dirty="0"/>
-              <a:t>Source: training PDF page 347. The training activity advances oxygen voltage 2, 4, and 6 seconds and plots T vs oxygen.</a:t>
-            </a:r>
+            <a:endParaRPr lang="en-US" dirty="0"/>
           </a:p>
         </p:txBody>
       </p:sp>
@@ -677,7 +672,10 @@
           <a:bodyPr/>
           <a:lstStyle/>
           <a:p>
-            <a:endParaRPr lang="en-US" dirty="0"/>
+            <a:r>
+              <a:rPr lang="en-US" dirty="0"/>
+              <a:t>Source: DOC/SBE_parameters.xlsx in the toolkit repo (Align block). Values are advances in seconds relative to pressure. Instruments with no value listed in the file show a dash. Only the SBE 25/25plus conductivity and oxygen values are highlighted in the file as checked against the Seasoft Data Processing manual; the file also carries a note 'My guess for Hogarth (SBE 25plus)' on a filter cell, so confirm other values against the manual for your own instrument. The file also lists filter time constants and cell thermal mass (alpha, beta) per instrument, and an 'align' row showing conductivity 0.0. The original text for the SBE 9plus oxygen entry reads '3 bis 5 (3.5)', meaning 3 to 5 s with 3.5 s as the typical value. Repository: https://github.com/GCOOS/SBE-Data-Processing-Toolkit</a:t>
+            </a:r>
           </a:p>
         </p:txBody>
       </p:sp>
@@ -699,93 +697,6 @@
             <a:fld id="{F7021451-1387-4CA6-816F-3879F97B5CBC}" type="slidenum">
               <a:rPr lang="en-US"/>
               <a:t>13</a:t>
-            </a:fld>
-            <a:endParaRPr lang="en-US"/>
-          </a:p>
-        </p:txBody>
-      </p:sp>
-    </p:spTree>
-    <p:extLst>
-      <p:ext uri="{BB962C8B-B14F-4D97-AF65-F5344CB8AC3E}">
-        <p14:creationId xmlns:p14="http://schemas.microsoft.com/office/powerpoint/2010/main" val="1024086991"/>
-      </p:ext>
-    </p:extLst>
-  </p:cSld>
-  <p:clrMapOvr>
-    <a:masterClrMapping/>
-  </p:clrMapOvr>
-</p:notes>
-</file>
-
-<file path=ppt/notesSlides/notesSlide14.xml><?xml version="1.0" encoding="utf-8"?>
-<p:notes xmlns:a="http://schemas.openxmlformats.org/drawingml/2006/main" xmlns:r="http://schemas.openxmlformats.org/officeDocument/2006/relationships" xmlns:p="http://schemas.openxmlformats.org/presentationml/2006/main">
-  <p:cSld>
-    <p:spTree>
-      <p:nvGrpSpPr>
-        <p:cNvPr id="1" name=""/>
-        <p:cNvGrpSpPr/>
-        <p:nvPr/>
-      </p:nvGrpSpPr>
-      <p:grpSpPr>
-        <a:xfrm>
-          <a:off x="0" y="0"/>
-          <a:ext cx="0" cy="0"/>
-          <a:chOff x="0" y="0"/>
-          <a:chExt cx="0" cy="0"/>
-        </a:xfrm>
-      </p:grpSpPr>
-      <p:sp>
-        <p:nvSpPr>
-          <p:cNvPr id="2" name="Slide Image Placeholder 1"/>
-          <p:cNvSpPr>
-            <a:spLocks noGrp="1" noRot="1" noChangeAspect="1"/>
-          </p:cNvSpPr>
-          <p:nvPr>
-            <p:ph type="sldImg"/>
-          </p:nvPr>
-        </p:nvSpPr>
-        <p:spPr/>
-      </p:sp>
-      <p:sp>
-        <p:nvSpPr>
-          <p:cNvPr id="3" name="Notes Placeholder 2"/>
-          <p:cNvSpPr>
-            <a:spLocks noGrp="1"/>
-          </p:cNvSpPr>
-          <p:nvPr>
-            <p:ph type="body" idx="1"/>
-          </p:nvPr>
-        </p:nvSpPr>
-        <p:spPr/>
-        <p:txBody>
-          <a:bodyPr/>
-          <a:lstStyle/>
-          <a:p>
-            <a:r>
-              <a:rPr lang="en-US" dirty="0"/>
-              <a:t>Source: DOC/SBE_parameters.xlsx in the toolkit repo (Align block). Values are advances in seconds relative to pressure. Instruments with no value listed in the file show a dash. Only the SBE 25/25plus conductivity and oxygen values are highlighted in the file as checked against the Seasoft Data Processing manual; the file also carries a note 'My guess for Hogarth (SBE 25plus)' on a filter cell, so confirm other values against the manual for your own instrument. The file also lists filter time constants and cell thermal mass (alpha, beta) per instrument, and an 'align' row showing conductivity 0.0. The original text for the SBE 9plus oxygen entry reads '3 bis 5 (3.5)', meaning 3 to 5 s with 3.5 s as the typical value. Repository: https://github.com/GCOOS/SBE-Data-Processing-Toolkit</a:t>
-            </a:r>
-          </a:p>
-        </p:txBody>
-      </p:sp>
-      <p:sp>
-        <p:nvSpPr>
-          <p:cNvPr id="4" name="Slide Number Placeholder 3"/>
-          <p:cNvSpPr>
-            <a:spLocks noGrp="1"/>
-          </p:cNvSpPr>
-          <p:nvPr>
-            <p:ph type="sldNum" sz="quarter" idx="10"/>
-          </p:nvPr>
-        </p:nvSpPr>
-        <p:spPr/>
-        <p:txBody>
-          <a:bodyPr/>
-          <a:lstStyle/>
-          <a:p>
-            <a:fld id="{F7021451-1387-4CA6-816F-3879F97B5CBC}" type="slidenum">
-              <a:rPr lang="en-US"/>
-              <a:t>14</a:t>
             </a:fld>
             <a:endParaRPr lang="en-US"/>
           </a:p>
@@ -1106,7 +1017,10 @@
           <a:bodyPr/>
           <a:lstStyle/>
           <a:p>
-            <a:endParaRPr lang="en-US" dirty="0"/>
+            <a:r>
+              <a:rPr lang="en-US" dirty="0"/>
+              <a:t>Source: SBE Data Processing training PDF, page 335 (Module 9). Blue is temperature, green conductivity, red salinity. The spike direction reverses if T and C decrease with depth. In the training example, 0.084 db equals 2 scans at the 9plus data rate and a 1 m/s lowering rate.</a:t>
+            </a:r>
           </a:p>
         </p:txBody>
       </p:sp>
@@ -1192,7 +1106,7 @@
           <a:p>
             <a:r>
               <a:rPr lang="en-US" dirty="0"/>
-              <a:t>Source: SBE Data Processing training PDF, page 335 (Module 9). Blue is temperature, green conductivity, red salinity. The spike direction reverses if T and C decrease with depth. In the training example, 0.084 db equals 2 scans at the 9plus data rate and a 1 m/s lowering rate.</a:t>
+              <a:t>Source: training PDF page 341. One scan (0.042 s) greatly improved the spiking; two scans began producing spikes in the other direction; three scans reversed and lengthened them. Non-integer scan shifts are allowed.</a:t>
             </a:r>
           </a:p>
         </p:txBody>
@@ -1279,7 +1193,7 @@
           <a:p>
             <a:r>
               <a:rPr lang="en-US" dirty="0"/>
-              <a:t>Source: training PDF page 341. One scan (0.042 s) greatly improved the spiking; two scans began producing spikes in the other direction; three scans reversed and lengthened them. Non-integer scan shifts are allowed.</a:t>
+              <a:t>Source: training PDF page 342 (extra-credit SBE 19plus data set). The optimal value there lies between 0.25 and 0.5 s. Results are compared with plot_alignment.py.</a:t>
             </a:r>
           </a:p>
         </p:txBody>
@@ -1366,7 +1280,7 @@
           <a:p>
             <a:r>
               <a:rPr lang="en-US" dirty="0"/>
-              <a:t>Source: training PDF page 342 (extra-credit SBE 19plus data set). The optimal value there lies between 0.25 and 0.5 s. Results are compared with plot_alignment.py.</a:t>
+              <a:t>Source: training PDF pages 343 and 344.</a:t>
             </a:r>
           </a:p>
         </p:txBody>
@@ -1453,7 +1367,7 @@
           <a:p>
             <a:r>
               <a:rPr lang="en-US" dirty="0"/>
-              <a:t>Source: training PDF pages 343 and 344.</a:t>
+              <a:t>Source: training PDF pages 344 and 345. Viewing hysteresis in DO-T space helps separate it from hydrographic features.</a:t>
             </a:r>
           </a:p>
         </p:txBody>
@@ -2363,374 +2277,6 @@
 
 <file path=ppt/slides/slide10.xml><?xml version="1.0" encoding="utf-8"?>
 <p:sld xmlns:a="http://schemas.openxmlformats.org/drawingml/2006/main" xmlns:r="http://schemas.openxmlformats.org/officeDocument/2006/relationships" xmlns:p="http://schemas.openxmlformats.org/presentationml/2006/main">
-  <p:cSld name="Slide 10">
-    <p:spTree>
-      <p:nvGrpSpPr>
-        <p:cNvPr id="1" name=""/>
-        <p:cNvGrpSpPr/>
-        <p:nvPr/>
-      </p:nvGrpSpPr>
-      <p:grpSpPr>
-        <a:xfrm>
-          <a:off x="0" y="0"/>
-          <a:ext cx="0" cy="0"/>
-          <a:chOff x="0" y="0"/>
-          <a:chExt cx="0" cy="0"/>
-        </a:xfrm>
-      </p:grpSpPr>
-      <p:sp>
-        <p:nvSpPr>
-          <p:cNvPr id="2" name="Text 0"/>
-          <p:cNvSpPr>
-            <a:spLocks noGrp="1"/>
-          </p:cNvSpPr>
-          <p:nvPr>
-            <p:ph type="title" idx="100" hasCustomPrompt="1"/>
-          </p:nvPr>
-        </p:nvSpPr>
-        <p:spPr>
-          <a:xfrm>
-            <a:off x="457200" y="274320"/>
-            <a:ext cx="8229600" cy="594360"/>
-          </a:xfrm>
-          <a:prstGeom prst="rect">
-            <a:avLst/>
-          </a:prstGeom>
-          <a:noFill/>
-          <a:ln/>
-        </p:spPr>
-        <p:txBody>
-          <a:bodyPr wrap="square" lIns="0" tIns="0" rIns="0" bIns="0" rtlCol="0" anchor="ctr"/>
-          <a:lstStyle/>
-          <a:p>
-            <a:pPr marL="0" indent="0" algn="l">
-              <a:buNone/>
-            </a:pPr>
-            <a:r>
-              <a:rPr lang="en-US" sz="3200" b="1" dirty="0">
-                <a:solidFill>
-                  <a:schemeClr val="tx1"/>
-                </a:solidFill>
-              </a:rPr>
-              <a:t>Hysteresis or a Real Feature?</a:t>
-            </a:r>
-            <a:endParaRPr lang="en-US" sz="3200" dirty="0"/>
-          </a:p>
-        </p:txBody>
-      </p:sp>
-      <p:sp>
-        <p:nvSpPr>
-          <p:cNvPr id="3" name="tagline"/>
-          <p:cNvSpPr txBox="1"/>
-          <p:nvPr/>
-        </p:nvSpPr>
-        <p:spPr>
-          <a:xfrm>
-            <a:off x="457200" y="896112"/>
-            <a:ext cx="8229600" cy="292608"/>
-          </a:xfrm>
-          <a:prstGeom prst="rect">
-            <a:avLst/>
-          </a:prstGeom>
-          <a:noFill/>
-          <a:ln/>
-        </p:spPr>
-        <p:txBody>
-          <a:bodyPr wrap="square" lIns="0" tIns="0" rIns="0" bIns="0" rtlCol="0" anchor="ctr"/>
-          <a:lstStyle/>
-          <a:p>
-            <a:pPr marL="0" indent="0">
-              <a:buNone/>
-            </a:pPr>
-            <a:r>
-              <a:rPr lang="en-US" sz="1500" i="1" dirty="0">
-                <a:solidFill>
-                  <a:schemeClr val="accent1"/>
-                </a:solidFill>
-              </a:rPr>
-              <a:t>Check before you shift the oxygen data</a:t>
-            </a:r>
-            <a:endParaRPr lang="en-US" sz="1500" dirty="0"/>
-          </a:p>
-        </p:txBody>
-      </p:sp>
-      <p:sp>
-        <p:nvSpPr>
-          <p:cNvPr id="4" name="bullets"/>
-          <p:cNvSpPr txBox="1"/>
-          <p:nvPr/>
-        </p:nvSpPr>
-        <p:spPr>
-          <a:xfrm>
-            <a:off x="457200" y="1417320"/>
-            <a:ext cx="3840480" cy="3108960"/>
-          </a:xfrm>
-          <a:prstGeom prst="rect">
-            <a:avLst/>
-          </a:prstGeom>
-          <a:noFill/>
-          <a:ln/>
-        </p:spPr>
-        <p:txBody>
-          <a:bodyPr wrap="square" lIns="0" tIns="0" rIns="0" bIns="0" rtlCol="0" anchor="t"/>
-          <a:lstStyle/>
-          <a:p>
-            <a:pPr marL="342900" indent="-342900">
-              <a:spcAft>
-                <a:spcPts val="700"/>
-              </a:spcAft>
-              <a:buSzPct val="100000"/>
-              <a:buChar char="•"/>
-            </a:pPr>
-            <a:r>
-              <a:rPr lang="en-US" sz="1300" dirty="0">
-                <a:solidFill>
-                  <a:schemeClr val="tx1"/>
-                </a:solidFill>
-              </a:rPr>
-              <a:t>Hysteresis is easy to see in pressure vs oxygen profiles</a:t>
-            </a:r>
-            <a:endParaRPr lang="en-US" sz="1300" dirty="0"/>
-          </a:p>
-          <a:p>
-            <a:pPr marL="342900" indent="-342900">
-              <a:spcAft>
-                <a:spcPts val="700"/>
-              </a:spcAft>
-              <a:buSzPct val="100000"/>
-              <a:buChar char="•"/>
-            </a:pPr>
-            <a:r>
-              <a:rPr lang="en-US" sz="1300" dirty="0">
-                <a:solidFill>
-                  <a:schemeClr val="tx1"/>
-                </a:solidFill>
-              </a:rPr>
-              <a:t>But real ocean features can look the same: a drifting ship near the Gulf Stream sampled a feature at different depths on down and upcast</a:t>
-            </a:r>
-            <a:endParaRPr lang="en-US" sz="1300" dirty="0"/>
-          </a:p>
-          <a:p>
-            <a:pPr marL="342900" indent="-342900">
-              <a:spcAft>
-                <a:spcPts val="700"/>
-              </a:spcAft>
-              <a:buSzPct val="100000"/>
-              <a:buChar char="•"/>
-            </a:pPr>
-            <a:r>
-              <a:rPr lang="en-US" sz="1300" dirty="0">
-                <a:solidFill>
-                  <a:schemeClr val="tx1"/>
-                </a:solidFill>
-              </a:rPr>
-              <a:t>Plot oxygen vs temperature to tell the two apart</a:t>
-            </a:r>
-            <a:endParaRPr lang="en-US" sz="1300" dirty="0"/>
-          </a:p>
-          <a:p>
-            <a:pPr marL="342900" indent="-342900">
-              <a:spcAft>
-                <a:spcPts val="700"/>
-              </a:spcAft>
-              <a:buSzPct val="100000"/>
-              <a:buChar char="•"/>
-            </a:pPr>
-            <a:r>
-              <a:rPr lang="en-US" sz="1300" dirty="0">
-                <a:solidFill>
-                  <a:schemeClr val="tx1"/>
-                </a:solidFill>
-              </a:rPr>
-              <a:t>Hydrographic phenomena should not be removed by data manipulation</a:t>
-            </a:r>
-            <a:endParaRPr lang="en-US" sz="1300" dirty="0"/>
-          </a:p>
-        </p:txBody>
-      </p:sp>
-      <p:sp>
-        <p:nvSpPr>
-          <p:cNvPr id="5" name="Oxygen vs temperature frame"/>
-          <p:cNvSpPr/>
-          <p:nvPr/>
-        </p:nvSpPr>
-        <p:spPr>
-          <a:xfrm>
-            <a:off x="4507992" y="1828441"/>
-            <a:ext cx="4197096" cy="1738077"/>
-          </a:xfrm>
-          <a:prstGeom prst="rect">
-            <a:avLst/>
-          </a:prstGeom>
-          <a:solidFill>
-            <a:schemeClr val="bg1"/>
-          </a:solidFill>
-          <a:ln w="9525">
-            <a:solidFill>
-              <a:schemeClr val="accent5"/>
-            </a:solidFill>
-            <a:prstDash val="solid"/>
-          </a:ln>
-        </p:spPr>
-        <p:txBody>
-          <a:bodyPr/>
-          <a:lstStyle/>
-          <a:p>
-            <a:endParaRPr lang="en-US"/>
-          </a:p>
-        </p:txBody>
-      </p:sp>
-      <p:pic>
-        <p:nvPicPr>
-          <p:cNvPr id="6" name="Oxygen vs temperature" descr="Oxygen vs temperature"/>
-          <p:cNvPicPr>
-            <a:picLocks noChangeAspect="1"/>
-          </p:cNvPicPr>
-          <p:nvPr/>
-        </p:nvPicPr>
-        <p:blipFill>
-          <a:blip r:embed="rId3"/>
-          <a:stretch>
-            <a:fillRect/>
-          </a:stretch>
-        </p:blipFill>
-        <p:spPr>
-          <a:xfrm>
-            <a:off x="4526280" y="1846729"/>
-            <a:ext cx="4160520" cy="1701501"/>
-          </a:xfrm>
-          <a:prstGeom prst="rect">
-            <a:avLst/>
-          </a:prstGeom>
-        </p:spPr>
-      </p:pic>
-      <p:sp>
-        <p:nvSpPr>
-          <p:cNvPr id="7" name="caption"/>
-          <p:cNvSpPr txBox="1"/>
-          <p:nvPr/>
-        </p:nvSpPr>
-        <p:spPr>
-          <a:xfrm>
-            <a:off x="4526280" y="3603095"/>
-            <a:ext cx="4160520" cy="274320"/>
-          </a:xfrm>
-          <a:prstGeom prst="rect">
-            <a:avLst/>
-          </a:prstGeom>
-          <a:noFill/>
-          <a:ln/>
-        </p:spPr>
-        <p:txBody>
-          <a:bodyPr wrap="square" lIns="0" tIns="0" rIns="0" bIns="0" rtlCol="0" anchor="ctr"/>
-          <a:lstStyle/>
-          <a:p>
-            <a:pPr marL="0" indent="0" algn="ctr">
-              <a:buNone/>
-            </a:pPr>
-            <a:r>
-              <a:rPr lang="en-US" sz="1100" i="1" dirty="0">
-                <a:solidFill>
-                  <a:schemeClr val="accent6"/>
-                </a:solidFill>
-              </a:rPr>
-              <a:t>Oxygen vs temperature plots for two casts</a:t>
-            </a:r>
-            <a:endParaRPr lang="en-US" sz="1100" dirty="0"/>
-          </a:p>
-        </p:txBody>
-      </p:sp>
-      <p:sp>
-        <p:nvSpPr>
-          <p:cNvPr id="8" name="source note"/>
-          <p:cNvSpPr txBox="1"/>
-          <p:nvPr/>
-        </p:nvSpPr>
-        <p:spPr>
-          <a:xfrm>
-            <a:off x="3474720" y="4754880"/>
-            <a:ext cx="4663440" cy="274320"/>
-          </a:xfrm>
-          <a:prstGeom prst="rect">
-            <a:avLst/>
-          </a:prstGeom>
-          <a:noFill/>
-          <a:ln/>
-        </p:spPr>
-        <p:txBody>
-          <a:bodyPr wrap="square" lIns="0" tIns="0" rIns="0" bIns="0" rtlCol="0" anchor="ctr"/>
-          <a:lstStyle/>
-          <a:p>
-            <a:pPr marL="0" indent="0" algn="r">
-              <a:buNone/>
-            </a:pPr>
-            <a:r>
-              <a:rPr lang="en-US" sz="900" dirty="0">
-                <a:solidFill>
-                  <a:schemeClr val="accent6"/>
-                </a:solidFill>
-              </a:rPr>
-              <a:t>Figure: Sea-Bird Scientific, SBE Data Processing training, Module 9</a:t>
-            </a:r>
-            <a:endParaRPr lang="en-US" sz="900" dirty="0"/>
-          </a:p>
-        </p:txBody>
-      </p:sp>
-      <p:sp>
-        <p:nvSpPr>
-          <p:cNvPr id="25" name="Slide Number Placeholder 0"/>
-          <p:cNvSpPr>
-            <a:spLocks noGrp="1"/>
-          </p:cNvSpPr>
-          <p:nvPr>
-            <p:ph type="sldNum" sz="quarter" idx="4294967295"/>
-          </p:nvPr>
-        </p:nvSpPr>
-        <p:spPr>
-          <a:xfrm>
-            <a:off x="8229600" y="4754880"/>
-            <a:ext cx="457200" cy="274320"/>
-          </a:xfrm>
-          <a:prstGeom prst="rect">
-            <a:avLst/>
-          </a:prstGeom>
-          <a:extLst>
-            <a:ext uri="{C572A759-6A51-4108-AA02-DFA0A04FC94B}">
-              <ma14:wrappingTextBoxFlag xmlns:ma14="http://schemas.microsoft.com/office/mac/drawingml/2011/main" xmlns="" val="0"/>
-            </a:ext>
-          </a:extLst>
-        </p:spPr>
-        <p:txBody>
-          <a:bodyPr/>
-          <a:lstStyle>
-            <a:lvl1pPr>
-              <a:defRPr sz="1000">
-                <a:solidFill>
-                  <a:schemeClr val="accent6"/>
-                </a:solidFill>
-              </a:defRPr>
-            </a:lvl1pPr>
-          </a:lstStyle>
-          <a:p>
-            <a:pPr algn="r"/>
-            <a:fld id="{F7021451-1387-4CA6-816F-3879F97B5CBC}" type="slidenum">
-              <a:rPr lang="en-US" b="0"/>
-              <a:t>10</a:t>
-            </a:fld>
-            <a:endParaRPr lang="en-US"/>
-          </a:p>
-        </p:txBody>
-      </p:sp>
-    </p:spTree>
-  </p:cSld>
-  <p:clrMapOvr>
-    <a:masterClrMapping/>
-  </p:clrMapOvr>
-</p:sld>
-</file>
-
-<file path=ppt/slides/slide11.xml><?xml version="1.0" encoding="utf-8"?>
-<p:sld xmlns:a="http://schemas.openxmlformats.org/drawingml/2006/main" xmlns:r="http://schemas.openxmlformats.org/officeDocument/2006/relationships" xmlns:p="http://schemas.openxmlformats.org/presentationml/2006/main">
   <p:cSld name="Slide 11">
     <p:spTree>
       <p:nvGrpSpPr>
@@ -3156,7 +2702,7 @@
             <a:pPr algn="r"/>
             <a:fld id="{F7021451-1387-4CA6-816F-3879F97B5CBC}" type="slidenum">
               <a:rPr lang="en-US" b="0"/>
-              <a:t>11</a:t>
+              <a:t>10</a:t>
             </a:fld>
             <a:endParaRPr lang="en-US"/>
           </a:p>
@@ -3170,7 +2716,7 @@
 </p:sld>
 </file>
 
-<file path=ppt/slides/slide12.xml><?xml version="1.0" encoding="utf-8"?>
+<file path=ppt/slides/slide11.xml><?xml version="1.0" encoding="utf-8"?>
 <p:sld xmlns:a="http://schemas.openxmlformats.org/drawingml/2006/main" xmlns:r="http://schemas.openxmlformats.org/officeDocument/2006/relationships" xmlns:p="http://schemas.openxmlformats.org/presentationml/2006/main">
   <p:cSld name="Slide 12">
     <p:spTree>
@@ -3494,7 +3040,7 @@
                   <a:schemeClr val="tx1"/>
                 </a:solidFill>
               </a:rPr>
-              <a:t>1  Pick one CNV file name</a:t>
+              <a:t>1  Select a cast / CNV file</a:t>
             </a:r>
             <a:endParaRPr lang="en-US" sz="1300" dirty="0"/>
           </a:p>
@@ -3555,32 +3101,25 @@
           <a:bodyPr wrap="square" lIns="0" tIns="0" rIns="0" bIns="0" rtlCol="0" anchor="ctr"/>
           <a:lstStyle/>
           <a:p>
-            <a:pPr marL="0" indent="0">
-              <a:buNone/>
-            </a:pPr>
             <a:r>
               <a:rPr lang="en-US" sz="1300" dirty="0">
                 <a:solidFill>
                   <a:schemeClr val="tx1"/>
                 </a:solidFill>
               </a:rPr>
-              <a:t>2  Choose </a:t>
-            </a:r>
-            <a:r>
-              <a:rPr lang="en-US" sz="1300">
+              <a:t>2  D</a:t>
+            </a:r>
+            <a:r>
+              <a:rPr lang="en-US" sz="1300" dirty="0"/>
+              <a:t>iscard </a:t>
+            </a:r>
+            <a:r>
+              <a:rPr lang="en-US" sz="1300" dirty="0">
                 <a:solidFill>
                   <a:schemeClr val="tx1"/>
                 </a:solidFill>
               </a:rPr>
-              <a:t># of initial </a:t>
-            </a:r>
-            <a:r>
-              <a:rPr lang="en-US" sz="1300" dirty="0">
-                <a:solidFill>
-                  <a:schemeClr val="tx1"/>
-                </a:solidFill>
-              </a:rPr>
-              <a:t>scans to discard</a:t>
+              <a:t>scans from beginning and end as necessary for clarity</a:t>
             </a:r>
             <a:endParaRPr lang="en-US" sz="1300" dirty="0"/>
           </a:p>
@@ -3720,7 +3259,7 @@
                   <a:schemeClr val="bg1"/>
                 </a:solidFill>
               </a:rPr>
-              <a:t>Custom X/Y axes tab for any pair</a:t>
+              <a:t>Custom X/Y axes tab for any pair. Useful for oxygen alignment: oxygen vs. temperature.</a:t>
             </a:r>
             <a:endParaRPr lang="en-US" sz="1300" dirty="0"/>
           </a:p>
@@ -3765,7 +3304,7 @@
             <a:pPr algn="r"/>
             <a:fld id="{F7021451-1387-4CA6-816F-3879F97B5CBC}" type="slidenum">
               <a:rPr lang="en-US" b="0"/>
-              <a:t>12</a:t>
+              <a:t>11</a:t>
             </a:fld>
             <a:endParaRPr lang="en-US"/>
           </a:p>
@@ -3779,7 +3318,7 @@
 </p:sld>
 </file>
 
-<file path=ppt/slides/slide13.xml><?xml version="1.0" encoding="utf-8"?>
+<file path=ppt/slides/slide12.xml><?xml version="1.0" encoding="utf-8"?>
 <p:sld xmlns:a="http://schemas.openxmlformats.org/drawingml/2006/main" xmlns:r="http://schemas.openxmlformats.org/officeDocument/2006/relationships" xmlns:p="http://schemas.openxmlformats.org/presentationml/2006/main">
   <p:cSld name="Slide 13">
     <p:spTree>
@@ -4715,7 +4254,7 @@
             <a:pPr algn="r"/>
             <a:fld id="{F7021451-1387-4CA6-816F-3879F97B5CBC}" type="slidenum">
               <a:rPr lang="en-US" b="0"/>
-              <a:t>13</a:t>
+              <a:t>12</a:t>
             </a:fld>
             <a:endParaRPr lang="en-US"/>
           </a:p>
@@ -4729,7 +4268,7 @@
 </p:sld>
 </file>
 
-<file path=ppt/slides/slide14.xml><?xml version="1.0" encoding="utf-8"?>
+<file path=ppt/slides/slide13.xml><?xml version="1.0" encoding="utf-8"?>
 <p:sld xmlns:a="http://schemas.openxmlformats.org/drawingml/2006/main" xmlns:r="http://schemas.openxmlformats.org/officeDocument/2006/relationships" xmlns:p="http://schemas.openxmlformats.org/presentationml/2006/main">
   <p:cSld name="Slide 14">
     <p:spTree>
@@ -5078,7 +4617,7 @@
         </p:nvSpPr>
         <p:spPr>
           <a:xfrm>
-            <a:off x="3200400" y="1691640"/>
+            <a:off x="3200400" y="1668780"/>
             <a:ext cx="1737360" cy="548640"/>
           </a:xfrm>
           <a:prstGeom prst="rect">
@@ -5738,42 +5277,6 @@
       </p:sp>
       <p:sp>
         <p:nvSpPr>
-          <p:cNvPr id="30" name="checked 22"/>
-          <p:cNvSpPr txBox="1"/>
-          <p:nvPr/>
-        </p:nvSpPr>
-        <p:spPr>
-          <a:xfrm>
-            <a:off x="6473952" y="2999232"/>
-            <a:ext cx="256032" cy="237744"/>
-          </a:xfrm>
-          <a:prstGeom prst="rect">
-            <a:avLst/>
-          </a:prstGeom>
-          <a:noFill/>
-          <a:ln/>
-        </p:spPr>
-        <p:txBody>
-          <a:bodyPr wrap="square" lIns="0" tIns="0" rIns="0" bIns="0" rtlCol="0" anchor="ctr"/>
-          <a:lstStyle/>
-          <a:p>
-            <a:pPr marL="0" indent="0" algn="r">
-              <a:buNone/>
-            </a:pPr>
-            <a:r>
-              <a:rPr lang="en-US" sz="1200" b="1" dirty="0">
-                <a:solidFill>
-                  <a:schemeClr val="accent1"/>
-                </a:solidFill>
-              </a:rPr>
-              <a:t>✓</a:t>
-            </a:r>
-            <a:endParaRPr lang="en-US" sz="1200" dirty="0"/>
-          </a:p>
-        </p:txBody>
-      </p:sp>
-      <p:sp>
-        <p:nvSpPr>
           <p:cNvPr id="31" name="Shape 29"/>
           <p:cNvSpPr/>
           <p:nvPr/>
@@ -5844,42 +5347,6 @@
       </p:sp>
       <p:sp>
         <p:nvSpPr>
-          <p:cNvPr id="33" name="checked 23"/>
-          <p:cNvSpPr txBox="1"/>
-          <p:nvPr/>
-        </p:nvSpPr>
-        <p:spPr>
-          <a:xfrm>
-            <a:off x="8394192" y="2999232"/>
-            <a:ext cx="256032" cy="237744"/>
-          </a:xfrm>
-          <a:prstGeom prst="rect">
-            <a:avLst/>
-          </a:prstGeom>
-          <a:noFill/>
-          <a:ln/>
-        </p:spPr>
-        <p:txBody>
-          <a:bodyPr wrap="square" lIns="0" tIns="0" rIns="0" bIns="0" rtlCol="0" anchor="ctr"/>
-          <a:lstStyle/>
-          <a:p>
-            <a:pPr marL="0" indent="0" algn="r">
-              <a:buNone/>
-            </a:pPr>
-            <a:r>
-              <a:rPr lang="en-US" sz="1200" b="1" dirty="0">
-                <a:solidFill>
-                  <a:schemeClr val="accent1"/>
-                </a:solidFill>
-              </a:rPr>
-              <a:t>✓</a:t>
-            </a:r>
-            <a:endParaRPr lang="en-US" sz="1200" dirty="0"/>
-          </a:p>
-        </p:txBody>
-      </p:sp>
-      <p:sp>
-        <p:nvSpPr>
           <p:cNvPr id="34" name="Shape 32"/>
           <p:cNvSpPr/>
           <p:nvPr/>
@@ -6160,42 +5627,6 @@
       </p:sp>
       <p:sp>
         <p:nvSpPr>
-          <p:cNvPr id="42" name="legend"/>
-          <p:cNvSpPr txBox="1"/>
-          <p:nvPr/>
-        </p:nvSpPr>
-        <p:spPr>
-          <a:xfrm>
-            <a:off x="457200" y="4279392"/>
-            <a:ext cx="8229600" cy="228600"/>
-          </a:xfrm>
-          <a:prstGeom prst="rect">
-            <a:avLst/>
-          </a:prstGeom>
-          <a:noFill/>
-          <a:ln/>
-        </p:spPr>
-        <p:txBody>
-          <a:bodyPr wrap="square" lIns="0" tIns="0" rIns="0" bIns="0" rtlCol="0" anchor="ctr"/>
-          <a:lstStyle/>
-          <a:p>
-            <a:pPr marL="0" indent="0">
-              <a:buNone/>
-            </a:pPr>
-            <a:r>
-              <a:rPr lang="en-US" sz="1100" dirty="0">
-                <a:solidFill>
-                  <a:schemeClr val="accent6"/>
-                </a:solidFill>
-              </a:rPr>
-              <a:t>✓ checked against the Seasoft manual in the source spreadsheet.  “-” = no value listed.</a:t>
-            </a:r>
-            <a:endParaRPr lang="en-US" sz="1100" dirty="0"/>
-          </a:p>
-        </p:txBody>
-      </p:sp>
-      <p:sp>
-        <p:nvSpPr>
           <p:cNvPr id="43" name="wrap up"/>
           <p:cNvSpPr txBox="1"/>
           <p:nvPr/>
@@ -6269,7 +5700,7 @@
             <a:pPr algn="r"/>
             <a:fld id="{F7021451-1387-4CA6-816F-3879F97B5CBC}" type="slidenum">
               <a:rPr lang="en-US" b="0"/>
-              <a:t>14</a:t>
+              <a:t>13</a:t>
             </a:fld>
             <a:endParaRPr lang="en-US"/>
           </a:p>
@@ -7291,7 +6722,7 @@
         <p:spPr>
           <a:xfrm>
             <a:off x="457200" y="1371600"/>
-            <a:ext cx="8229600" cy="640080"/>
+            <a:ext cx="7406640" cy="640080"/>
           </a:xfrm>
           <a:prstGeom prst="roundRect">
             <a:avLst>
@@ -7325,7 +6756,7 @@
         <p:spPr>
           <a:xfrm>
             <a:off x="640080" y="1371600"/>
-            <a:ext cx="7863840" cy="640080"/>
+            <a:ext cx="6727874" cy="640080"/>
           </a:xfrm>
           <a:prstGeom prst="rect">
             <a:avLst/>
@@ -7346,7 +6777,7 @@
                   <a:schemeClr val="bg1"/>
                 </a:solidFill>
               </a:rPr>
-              <a:t>Prepare the cruise folder: init script, copy casts to CNV, rename files, check naming</a:t>
+              <a:t>Prepare the cruise folder: init script, copy data to CNV, rename files, check naming</a:t>
             </a:r>
             <a:endParaRPr lang="en-US" sz="1500" dirty="0"/>
           </a:p>
@@ -7445,7 +6876,7 @@
         <p:spPr>
           <a:xfrm>
             <a:off x="2331720" y="2240280"/>
-            <a:ext cx="4572000" cy="731520"/>
+            <a:ext cx="3658772" cy="731520"/>
           </a:xfrm>
           <a:prstGeom prst="roundRect">
             <a:avLst>
@@ -7514,7 +6945,7 @@
         </p:nvSpPr>
         <p:spPr>
           <a:xfrm>
-            <a:off x="7040880" y="2240280"/>
+            <a:off x="6217920" y="2240280"/>
             <a:ext cx="1645920" cy="731520"/>
           </a:xfrm>
           <a:prstGeom prst="roundRect">
@@ -7548,7 +6979,7 @@
         </p:nvSpPr>
         <p:spPr>
           <a:xfrm>
-            <a:off x="7040880" y="2240280"/>
+            <a:off x="6217920" y="2240280"/>
             <a:ext cx="1645920" cy="731520"/>
           </a:xfrm>
           <a:prstGeom prst="rect">
@@ -7585,7 +7016,7 @@
         <p:spPr>
           <a:xfrm>
             <a:off x="457200" y="3200400"/>
-            <a:ext cx="1737360" cy="1325880"/>
+            <a:ext cx="1737360" cy="1107831"/>
           </a:xfrm>
           <a:prstGeom prst="roundRect">
             <a:avLst>
@@ -7619,7 +7050,7 @@
         <p:spPr>
           <a:xfrm>
             <a:off x="457200" y="3200400"/>
-            <a:ext cx="1737360" cy="1325880"/>
+            <a:ext cx="1737360" cy="1107831"/>
           </a:xfrm>
           <a:prstGeom prst="rect">
             <a:avLst/>
@@ -7669,7 +7100,7 @@
         <p:spPr>
           <a:xfrm>
             <a:off x="2331720" y="3200400"/>
-            <a:ext cx="1188720" cy="1325880"/>
+            <a:ext cx="1188720" cy="1107831"/>
           </a:xfrm>
           <a:prstGeom prst="roundRect">
             <a:avLst>
@@ -7771,7 +7202,7 @@
         <p:spPr>
           <a:xfrm>
             <a:off x="2395728" y="3703320"/>
-            <a:ext cx="1060704" cy="777240"/>
+            <a:ext cx="1060704" cy="645942"/>
           </a:xfrm>
           <a:prstGeom prst="rect">
             <a:avLst/>
@@ -7792,7 +7223,7 @@
                   <a:schemeClr val="tx1"/>
                 </a:solidFill>
               </a:rPr>
-              <a:t>Convert downcast only (in CNV)</a:t>
+              <a:t>Convert downcast and upcast (in CNV)</a:t>
             </a:r>
             <a:endParaRPr lang="en-US" sz="1100" dirty="0"/>
           </a:p>
@@ -7800,14 +7231,14 @@
       </p:sp>
       <p:sp>
         <p:nvSpPr>
-          <p:cNvPr id="18" name="Shape 16"/>
+          <p:cNvPr id="26" name="Shape 24"/>
           <p:cNvSpPr/>
           <p:nvPr/>
         </p:nvSpPr>
         <p:spPr>
           <a:xfrm>
-            <a:off x="3621024" y="3200400"/>
-            <a:ext cx="1188720" cy="1325880"/>
+            <a:off x="3632295" y="3200400"/>
+            <a:ext cx="1188720" cy="1107831"/>
           </a:xfrm>
           <a:prstGeom prst="roundRect">
             <a:avLst>
@@ -7834,13 +7265,13 @@
       </p:sp>
       <p:sp>
         <p:nvSpPr>
-          <p:cNvPr id="19" name="step badge 2"/>
+          <p:cNvPr id="27" name="step badge 4"/>
           <p:cNvSpPr/>
           <p:nvPr/>
         </p:nvSpPr>
         <p:spPr>
           <a:xfrm>
-            <a:off x="4032504" y="3273552"/>
+            <a:off x="4043775" y="3273552"/>
             <a:ext cx="365760" cy="365760"/>
           </a:xfrm>
           <a:prstGeom prst="ellipse">
@@ -7866,13 +7297,13 @@
       </p:sp>
       <p:sp>
         <p:nvSpPr>
-          <p:cNvPr id="20" name="step num 2"/>
+          <p:cNvPr id="28" name="step num 4"/>
           <p:cNvSpPr txBox="1"/>
           <p:nvPr/>
         </p:nvSpPr>
         <p:spPr>
           <a:xfrm>
-            <a:off x="4032504" y="3273552"/>
+            <a:off x="4043775" y="3273552"/>
             <a:ext cx="365760" cy="365760"/>
           </a:xfrm>
           <a:prstGeom prst="rect">
@@ -7902,14 +7333,14 @@
       </p:sp>
       <p:sp>
         <p:nvSpPr>
-          <p:cNvPr id="21" name="step text 2"/>
+          <p:cNvPr id="29" name="step text 4"/>
           <p:cNvSpPr txBox="1"/>
           <p:nvPr/>
         </p:nvSpPr>
         <p:spPr>
           <a:xfrm>
-            <a:off x="3685032" y="3703320"/>
-            <a:ext cx="1060704" cy="777240"/>
+            <a:off x="3696303" y="3703320"/>
+            <a:ext cx="1060704" cy="604911"/>
           </a:xfrm>
           <a:prstGeom prst="rect">
             <a:avLst/>
@@ -7930,7 +7361,7 @@
                   <a:schemeClr val="tx1"/>
                 </a:solidFill>
               </a:rPr>
-              <a:t>Check that downcast kept enough data</a:t>
+              <a:t>Run TC and O experiments; review plots</a:t>
             </a:r>
             <a:endParaRPr lang="en-US" sz="1100" dirty="0"/>
           </a:p>
@@ -7938,14 +7369,14 @@
       </p:sp>
       <p:sp>
         <p:nvSpPr>
-          <p:cNvPr id="22" name="Shape 20"/>
+          <p:cNvPr id="30" name="Shape 28"/>
           <p:cNvSpPr/>
           <p:nvPr/>
         </p:nvSpPr>
         <p:spPr>
           <a:xfrm>
-            <a:off x="4910328" y="3200400"/>
-            <a:ext cx="1188720" cy="1325880"/>
+            <a:off x="4921599" y="3200400"/>
+            <a:ext cx="1188720" cy="1107831"/>
           </a:xfrm>
           <a:prstGeom prst="roundRect">
             <a:avLst>
@@ -7972,13 +7403,13 @@
       </p:sp>
       <p:sp>
         <p:nvSpPr>
-          <p:cNvPr id="23" name="step badge 3"/>
+          <p:cNvPr id="31" name="step badge 5"/>
           <p:cNvSpPr/>
           <p:nvPr/>
         </p:nvSpPr>
         <p:spPr>
           <a:xfrm>
-            <a:off x="5321808" y="3273552"/>
+            <a:off x="5333079" y="3273552"/>
             <a:ext cx="365760" cy="365760"/>
           </a:xfrm>
           <a:prstGeom prst="ellipse">
@@ -8004,289 +7435,13 @@
       </p:sp>
       <p:sp>
         <p:nvSpPr>
-          <p:cNvPr id="24" name="step num 3"/>
-          <p:cNvSpPr txBox="1"/>
-          <p:nvPr/>
-        </p:nvSpPr>
-        <p:spPr>
-          <a:xfrm>
-            <a:off x="5321808" y="3273552"/>
-            <a:ext cx="365760" cy="365760"/>
-          </a:xfrm>
-          <a:prstGeom prst="rect">
-            <a:avLst/>
-          </a:prstGeom>
-          <a:noFill/>
-          <a:ln/>
-        </p:spPr>
-        <p:txBody>
-          <a:bodyPr wrap="square" lIns="0" tIns="0" rIns="0" bIns="0" rtlCol="0" anchor="ctr"/>
-          <a:lstStyle/>
-          <a:p>
-            <a:pPr marL="0" indent="0" algn="ctr">
-              <a:buNone/>
-            </a:pPr>
-            <a:r>
-              <a:rPr lang="en-US" sz="1300" b="1" dirty="0">
-                <a:solidFill>
-                  <a:schemeClr val="bg1"/>
-                </a:solidFill>
-              </a:rPr>
-              <a:t>3</a:t>
-            </a:r>
-            <a:endParaRPr lang="en-US" sz="1300" dirty="0"/>
-          </a:p>
-        </p:txBody>
-      </p:sp>
-      <p:sp>
-        <p:nvSpPr>
-          <p:cNvPr id="25" name="step text 3"/>
-          <p:cNvSpPr txBox="1"/>
-          <p:nvPr/>
-        </p:nvSpPr>
-        <p:spPr>
-          <a:xfrm>
-            <a:off x="4974336" y="3703320"/>
-            <a:ext cx="1060704" cy="777240"/>
-          </a:xfrm>
-          <a:prstGeom prst="rect">
-            <a:avLst/>
-          </a:prstGeom>
-          <a:noFill/>
-          <a:ln/>
-        </p:spPr>
-        <p:txBody>
-          <a:bodyPr wrap="square" lIns="0" tIns="0" rIns="0" bIns="0" rtlCol="0" anchor="t"/>
-          <a:lstStyle/>
-          <a:p>
-            <a:pPr marL="0" indent="0" algn="ctr">
-              <a:buNone/>
-            </a:pPr>
-            <a:r>
-              <a:rPr lang="en-US" sz="1100" dirty="0">
-                <a:solidFill>
-                  <a:schemeClr val="tx1"/>
-                </a:solidFill>
-              </a:rPr>
-              <a:t>Re-convert short casts in UPDOWN</a:t>
-            </a:r>
-            <a:endParaRPr lang="en-US" sz="1100" dirty="0"/>
-          </a:p>
-        </p:txBody>
-      </p:sp>
-      <p:sp>
-        <p:nvSpPr>
-          <p:cNvPr id="26" name="Shape 24"/>
-          <p:cNvSpPr/>
-          <p:nvPr/>
-        </p:nvSpPr>
-        <p:spPr>
-          <a:xfrm>
-            <a:off x="6199632" y="3200400"/>
-            <a:ext cx="1188720" cy="1325880"/>
-          </a:xfrm>
-          <a:prstGeom prst="roundRect">
-            <a:avLst>
-              <a:gd name="adj" fmla="val 7692"/>
-            </a:avLst>
-          </a:prstGeom>
-          <a:solidFill>
-            <a:schemeClr val="bg2"/>
-          </a:solidFill>
-          <a:ln w="12700">
-            <a:solidFill>
-              <a:schemeClr val="bg2"/>
-            </a:solidFill>
-            <a:prstDash val="solid"/>
-          </a:ln>
-        </p:spPr>
-        <p:txBody>
-          <a:bodyPr/>
-          <a:lstStyle/>
-          <a:p>
-            <a:endParaRPr lang="en-US"/>
-          </a:p>
-        </p:txBody>
-      </p:sp>
-      <p:sp>
-        <p:nvSpPr>
-          <p:cNvPr id="27" name="step badge 4"/>
-          <p:cNvSpPr/>
-          <p:nvPr/>
-        </p:nvSpPr>
-        <p:spPr>
-          <a:xfrm>
-            <a:off x="6611112" y="3273552"/>
-            <a:ext cx="365760" cy="365760"/>
-          </a:xfrm>
-          <a:prstGeom prst="ellipse">
-            <a:avLst/>
-          </a:prstGeom>
-          <a:solidFill>
-            <a:schemeClr val="accent1"/>
-          </a:solidFill>
-          <a:ln w="12700">
-            <a:solidFill>
-              <a:schemeClr val="accent1"/>
-            </a:solidFill>
-            <a:prstDash val="solid"/>
-          </a:ln>
-        </p:spPr>
-        <p:txBody>
-          <a:bodyPr/>
-          <a:lstStyle/>
-          <a:p>
-            <a:endParaRPr lang="en-US"/>
-          </a:p>
-        </p:txBody>
-      </p:sp>
-      <p:sp>
-        <p:nvSpPr>
-          <p:cNvPr id="28" name="step num 4"/>
-          <p:cNvSpPr txBox="1"/>
-          <p:nvPr/>
-        </p:nvSpPr>
-        <p:spPr>
-          <a:xfrm>
-            <a:off x="6611112" y="3273552"/>
-            <a:ext cx="365760" cy="365760"/>
-          </a:xfrm>
-          <a:prstGeom prst="rect">
-            <a:avLst/>
-          </a:prstGeom>
-          <a:noFill/>
-          <a:ln/>
-        </p:spPr>
-        <p:txBody>
-          <a:bodyPr wrap="square" lIns="0" tIns="0" rIns="0" bIns="0" rtlCol="0" anchor="ctr"/>
-          <a:lstStyle/>
-          <a:p>
-            <a:pPr marL="0" indent="0" algn="ctr">
-              <a:buNone/>
-            </a:pPr>
-            <a:r>
-              <a:rPr lang="en-US" sz="1300" b="1" dirty="0">
-                <a:solidFill>
-                  <a:schemeClr val="bg1"/>
-                </a:solidFill>
-              </a:rPr>
-              <a:t>4</a:t>
-            </a:r>
-            <a:endParaRPr lang="en-US" sz="1300" dirty="0"/>
-          </a:p>
-        </p:txBody>
-      </p:sp>
-      <p:sp>
-        <p:nvSpPr>
-          <p:cNvPr id="29" name="step text 4"/>
-          <p:cNvSpPr txBox="1"/>
-          <p:nvPr/>
-        </p:nvSpPr>
-        <p:spPr>
-          <a:xfrm>
-            <a:off x="6263640" y="3703320"/>
-            <a:ext cx="1060704" cy="777240"/>
-          </a:xfrm>
-          <a:prstGeom prst="rect">
-            <a:avLst/>
-          </a:prstGeom>
-          <a:noFill/>
-          <a:ln/>
-        </p:spPr>
-        <p:txBody>
-          <a:bodyPr wrap="square" lIns="0" tIns="0" rIns="0" bIns="0" rtlCol="0" anchor="t"/>
-          <a:lstStyle/>
-          <a:p>
-            <a:pPr marL="0" indent="0" algn="ctr">
-              <a:buNone/>
-            </a:pPr>
-            <a:r>
-              <a:rPr lang="en-US" sz="1100" dirty="0">
-                <a:solidFill>
-                  <a:schemeClr val="tx1"/>
-                </a:solidFill>
-              </a:rPr>
-              <a:t>Run TC and O experiments; review plots</a:t>
-            </a:r>
-            <a:endParaRPr lang="en-US" sz="1100" dirty="0"/>
-          </a:p>
-        </p:txBody>
-      </p:sp>
-      <p:sp>
-        <p:nvSpPr>
-          <p:cNvPr id="30" name="Shape 28"/>
-          <p:cNvSpPr/>
-          <p:nvPr/>
-        </p:nvSpPr>
-        <p:spPr>
-          <a:xfrm>
-            <a:off x="7488936" y="3200400"/>
-            <a:ext cx="1188720" cy="1325880"/>
-          </a:xfrm>
-          <a:prstGeom prst="roundRect">
-            <a:avLst>
-              <a:gd name="adj" fmla="val 7692"/>
-            </a:avLst>
-          </a:prstGeom>
-          <a:solidFill>
-            <a:schemeClr val="bg2"/>
-          </a:solidFill>
-          <a:ln w="12700">
-            <a:solidFill>
-              <a:schemeClr val="bg2"/>
-            </a:solidFill>
-            <a:prstDash val="solid"/>
-          </a:ln>
-        </p:spPr>
-        <p:txBody>
-          <a:bodyPr/>
-          <a:lstStyle/>
-          <a:p>
-            <a:endParaRPr lang="en-US"/>
-          </a:p>
-        </p:txBody>
-      </p:sp>
-      <p:sp>
-        <p:nvSpPr>
-          <p:cNvPr id="31" name="step badge 5"/>
-          <p:cNvSpPr/>
-          <p:nvPr/>
-        </p:nvSpPr>
-        <p:spPr>
-          <a:xfrm>
-            <a:off x="7900416" y="3273552"/>
-            <a:ext cx="365760" cy="365760"/>
-          </a:xfrm>
-          <a:prstGeom prst="ellipse">
-            <a:avLst/>
-          </a:prstGeom>
-          <a:solidFill>
-            <a:schemeClr val="accent1"/>
-          </a:solidFill>
-          <a:ln w="12700">
-            <a:solidFill>
-              <a:schemeClr val="accent1"/>
-            </a:solidFill>
-            <a:prstDash val="solid"/>
-          </a:ln>
-        </p:spPr>
-        <p:txBody>
-          <a:bodyPr/>
-          <a:lstStyle/>
-          <a:p>
-            <a:endParaRPr lang="en-US"/>
-          </a:p>
-        </p:txBody>
-      </p:sp>
-      <p:sp>
-        <p:nvSpPr>
           <p:cNvPr id="32" name="step num 5"/>
           <p:cNvSpPr txBox="1"/>
           <p:nvPr/>
         </p:nvSpPr>
         <p:spPr>
           <a:xfrm>
-            <a:off x="7900416" y="3273552"/>
+            <a:off x="5333079" y="3273552"/>
             <a:ext cx="365760" cy="365760"/>
           </a:xfrm>
           <a:prstGeom prst="rect">
@@ -8308,7 +7463,7 @@
                   <a:schemeClr val="bg1"/>
                 </a:solidFill>
               </a:rPr>
-              <a:t>5</a:t>
+              <a:t>3</a:t>
             </a:r>
             <a:endParaRPr lang="en-US" sz="1300" dirty="0"/>
           </a:p>
@@ -8322,8 +7477,8 @@
         </p:nvSpPr>
         <p:spPr>
           <a:xfrm>
-            <a:off x="7552944" y="3703320"/>
-            <a:ext cx="1060704" cy="777240"/>
+            <a:off x="4985607" y="3703320"/>
+            <a:ext cx="1060704" cy="604911"/>
           </a:xfrm>
           <a:prstGeom prst="rect">
             <a:avLst/>
@@ -8392,6 +7547,88 @@
               <a:t>3</a:t>
             </a:fld>
             <a:endParaRPr lang="en-US"/>
+          </a:p>
+        </p:txBody>
+      </p:sp>
+      <p:sp>
+        <p:nvSpPr>
+          <p:cNvPr id="37" name="Shape 8">
+            <a:extLst>
+              <a:ext uri="{FF2B5EF4-FFF2-40B4-BE49-F238E27FC236}">
+                <a16:creationId xmlns:a16="http://schemas.microsoft.com/office/drawing/2014/main" id="{9EE7FD3C-728F-B573-DFBA-AD478A522D17}"/>
+              </a:ext>
+            </a:extLst>
+          </p:cNvPr>
+          <p:cNvSpPr/>
+          <p:nvPr/>
+        </p:nvSpPr>
+        <p:spPr>
+          <a:xfrm>
+            <a:off x="6217920" y="3200400"/>
+            <a:ext cx="1645920" cy="1107831"/>
+          </a:xfrm>
+          <a:prstGeom prst="roundRect">
+            <a:avLst>
+              <a:gd name="adj" fmla="val 12500"/>
+            </a:avLst>
+          </a:prstGeom>
+          <a:solidFill>
+            <a:schemeClr val="accent5"/>
+          </a:solidFill>
+          <a:ln w="12700">
+            <a:solidFill>
+              <a:schemeClr val="accent5"/>
+            </a:solidFill>
+            <a:prstDash val="solid"/>
+          </a:ln>
+        </p:spPr>
+        <p:txBody>
+          <a:bodyPr/>
+          <a:lstStyle/>
+          <a:p>
+            <a:endParaRPr lang="en-US"/>
+          </a:p>
+        </p:txBody>
+      </p:sp>
+      <p:sp>
+        <p:nvSpPr>
+          <p:cNvPr id="38" name="opt1 done">
+            <a:extLst>
+              <a:ext uri="{FF2B5EF4-FFF2-40B4-BE49-F238E27FC236}">
+                <a16:creationId xmlns:a16="http://schemas.microsoft.com/office/drawing/2014/main" id="{7D877BB3-34B4-B5EE-2A8B-C276AAB2CF90}"/>
+              </a:ext>
+            </a:extLst>
+          </p:cNvPr>
+          <p:cNvSpPr txBox="1"/>
+          <p:nvPr/>
+        </p:nvSpPr>
+        <p:spPr>
+          <a:xfrm>
+            <a:off x="6217920" y="3200400"/>
+            <a:ext cx="1645920" cy="1107831"/>
+          </a:xfrm>
+          <a:prstGeom prst="rect">
+            <a:avLst/>
+          </a:prstGeom>
+          <a:noFill/>
+          <a:ln/>
+        </p:spPr>
+        <p:txBody>
+          <a:bodyPr wrap="square" lIns="0" tIns="0" rIns="0" bIns="0" rtlCol="0" anchor="ctr"/>
+          <a:lstStyle/>
+          <a:p>
+            <a:pPr marL="0" indent="0" algn="ctr">
+              <a:buNone/>
+            </a:pPr>
+            <a:r>
+              <a:rPr lang="en-US" sz="1600" b="1" dirty="0">
+                <a:solidFill>
+                  <a:schemeClr val="tx1"/>
+                </a:solidFill>
+              </a:rPr>
+              <a:t>Done</a:t>
+            </a:r>
+            <a:endParaRPr lang="en-US" sz="1600" dirty="0"/>
           </a:p>
         </p:txBody>
       </p:sp>
@@ -8584,7 +7821,7 @@
                   <a:schemeClr val="tx1"/>
                 </a:solidFill>
               </a:rPr>
-              <a:t>Cast number is optional, needed only to separate casts at one station</a:t>
+              <a:t>Cast number is optional, needed only to separate casts at one station3</a:t>
             </a:r>
             <a:endParaRPr lang="en-US" sz="1500" dirty="0"/>
           </a:p>
@@ -8941,626 +8178,6 @@
 </file>
 
 <file path=ppt/slides/slide5.xml><?xml version="1.0" encoding="utf-8"?>
-<p:sld xmlns:a="http://schemas.openxmlformats.org/drawingml/2006/main" xmlns:r="http://schemas.openxmlformats.org/officeDocument/2006/relationships" xmlns:p="http://schemas.openxmlformats.org/presentationml/2006/main">
-  <p:cSld name="Slide 5">
-    <p:spTree>
-      <p:nvGrpSpPr>
-        <p:cNvPr id="1" name=""/>
-        <p:cNvGrpSpPr/>
-        <p:nvPr/>
-      </p:nvGrpSpPr>
-      <p:grpSpPr>
-        <a:xfrm>
-          <a:off x="0" y="0"/>
-          <a:ext cx="0" cy="0"/>
-          <a:chOff x="0" y="0"/>
-          <a:chExt cx="0" cy="0"/>
-        </a:xfrm>
-      </p:grpSpPr>
-      <p:sp>
-        <p:nvSpPr>
-          <p:cNvPr id="2" name="Text 0"/>
-          <p:cNvSpPr>
-            <a:spLocks noGrp="1"/>
-          </p:cNvSpPr>
-          <p:nvPr>
-            <p:ph type="title" idx="100" hasCustomPrompt="1"/>
-          </p:nvPr>
-        </p:nvSpPr>
-        <p:spPr>
-          <a:xfrm>
-            <a:off x="457200" y="274320"/>
-            <a:ext cx="8229600" cy="594360"/>
-          </a:xfrm>
-          <a:prstGeom prst="rect">
-            <a:avLst/>
-          </a:prstGeom>
-          <a:noFill/>
-          <a:ln/>
-        </p:spPr>
-        <p:txBody>
-          <a:bodyPr wrap="square" lIns="0" tIns="0" rIns="0" bIns="0" rtlCol="0" anchor="ctr"/>
-          <a:lstStyle/>
-          <a:p>
-            <a:pPr marL="0" indent="0" algn="l">
-              <a:buNone/>
-            </a:pPr>
-            <a:r>
-              <a:rPr lang="en-US" sz="3200" b="1" dirty="0">
-                <a:solidFill>
-                  <a:schemeClr val="tx1"/>
-                </a:solidFill>
-              </a:rPr>
-              <a:t>Check the Downcast Detection</a:t>
-            </a:r>
-            <a:endParaRPr lang="en-US" sz="3200" dirty="0"/>
-          </a:p>
-        </p:txBody>
-      </p:sp>
-      <p:sp>
-        <p:nvSpPr>
-          <p:cNvPr id="3" name="tagline"/>
-          <p:cNvSpPr txBox="1"/>
-          <p:nvPr/>
-        </p:nvSpPr>
-        <p:spPr>
-          <a:xfrm>
-            <a:off x="457200" y="896112"/>
-            <a:ext cx="8229600" cy="292608"/>
-          </a:xfrm>
-          <a:prstGeom prst="rect">
-            <a:avLst/>
-          </a:prstGeom>
-          <a:noFill/>
-          <a:ln/>
-        </p:spPr>
-        <p:txBody>
-          <a:bodyPr wrap="square" lIns="0" tIns="0" rIns="0" bIns="0" rtlCol="0" anchor="ctr"/>
-          <a:lstStyle/>
-          <a:p>
-            <a:pPr marL="0" indent="0">
-              <a:buNone/>
-            </a:pPr>
-            <a:r>
-              <a:rPr lang="en-US" sz="1500" i="1" dirty="0">
-                <a:solidFill>
-                  <a:schemeClr val="accent1"/>
-                </a:solidFill>
-              </a:rPr>
-              <a:t>Find casts where Sea-Bird kept too little data</a:t>
-            </a:r>
-            <a:endParaRPr lang="en-US" sz="1500" dirty="0"/>
-          </a:p>
-        </p:txBody>
-      </p:sp>
-      <p:sp>
-        <p:nvSpPr>
-          <p:cNvPr id="4" name="Shape 2"/>
-          <p:cNvSpPr/>
-          <p:nvPr/>
-        </p:nvSpPr>
-        <p:spPr>
-          <a:xfrm>
-            <a:off x="457200" y="1371600"/>
-            <a:ext cx="4023360" cy="2743200"/>
-          </a:xfrm>
-          <a:prstGeom prst="roundRect">
-            <a:avLst>
-              <a:gd name="adj" fmla="val 3333"/>
-            </a:avLst>
-          </a:prstGeom>
-          <a:solidFill>
-            <a:schemeClr val="bg2"/>
-          </a:solidFill>
-          <a:ln w="12700">
-            <a:solidFill>
-              <a:schemeClr val="bg2"/>
-            </a:solidFill>
-            <a:prstDash val="solid"/>
-          </a:ln>
-        </p:spPr>
-        <p:txBody>
-          <a:bodyPr/>
-          <a:lstStyle/>
-          <a:p>
-            <a:endParaRPr lang="en-US"/>
-          </a:p>
-        </p:txBody>
-      </p:sp>
-      <p:sp>
-        <p:nvSpPr>
-          <p:cNvPr id="5" name="path title 0"/>
-          <p:cNvSpPr txBox="1"/>
-          <p:nvPr/>
-        </p:nvSpPr>
-        <p:spPr>
-          <a:xfrm>
-            <a:off x="640080" y="1463040"/>
-            <a:ext cx="3657600" cy="365760"/>
-          </a:xfrm>
-          <a:prstGeom prst="rect">
-            <a:avLst/>
-          </a:prstGeom>
-          <a:noFill/>
-          <a:ln/>
-        </p:spPr>
-        <p:txBody>
-          <a:bodyPr wrap="square" lIns="0" tIns="0" rIns="0" bIns="0" rtlCol="0" anchor="ctr"/>
-          <a:lstStyle/>
-          <a:p>
-            <a:pPr marL="0" indent="0">
-              <a:buNone/>
-            </a:pPr>
-            <a:r>
-              <a:rPr lang="en-US" sz="1800" b="1" dirty="0">
-                <a:solidFill>
-                  <a:schemeClr val="accent1"/>
-                </a:solidFill>
-              </a:rPr>
-              <a:t>Pump status available</a:t>
-            </a:r>
-            <a:endParaRPr lang="en-US" sz="1800" dirty="0"/>
-          </a:p>
-        </p:txBody>
-      </p:sp>
-      <p:sp>
-        <p:nvSpPr>
-          <p:cNvPr id="6" name="Shape 4"/>
-          <p:cNvSpPr/>
-          <p:nvPr/>
-        </p:nvSpPr>
-        <p:spPr>
-          <a:xfrm>
-            <a:off x="640080" y="1920240"/>
-            <a:ext cx="3657600" cy="457200"/>
-          </a:xfrm>
-          <a:prstGeom prst="roundRect">
-            <a:avLst>
-              <a:gd name="adj" fmla="val 16000"/>
-            </a:avLst>
-          </a:prstGeom>
-          <a:solidFill>
-            <a:schemeClr val="tx1"/>
-          </a:solidFill>
-          <a:ln w="12700">
-            <a:solidFill>
-              <a:schemeClr val="tx1"/>
-            </a:solidFill>
-            <a:prstDash val="solid"/>
-          </a:ln>
-        </p:spPr>
-        <p:txBody>
-          <a:bodyPr/>
-          <a:lstStyle/>
-          <a:p>
-            <a:endParaRPr lang="en-US"/>
-          </a:p>
-        </p:txBody>
-      </p:sp>
-      <p:sp>
-        <p:nvSpPr>
-          <p:cNvPr id="7" name="command"/>
-          <p:cNvSpPr txBox="1"/>
-          <p:nvPr/>
-        </p:nvSpPr>
-        <p:spPr>
-          <a:xfrm>
-            <a:off x="749808" y="1920240"/>
-            <a:ext cx="3438144" cy="457200"/>
-          </a:xfrm>
-          <a:prstGeom prst="rect">
-            <a:avLst/>
-          </a:prstGeom>
-          <a:noFill/>
-          <a:ln/>
-        </p:spPr>
-        <p:txBody>
-          <a:bodyPr wrap="square" lIns="0" tIns="0" rIns="0" bIns="0" rtlCol="0" anchor="ctr"/>
-          <a:lstStyle/>
-          <a:p>
-            <a:pPr marL="0" indent="0">
-              <a:buNone/>
-            </a:pPr>
-            <a:r>
-              <a:rPr lang="en-US" sz="950" dirty="0">
-                <a:solidFill>
-                  <a:schemeClr val="bg1"/>
-                </a:solidFill>
-                <a:latin typeface="Consolas" pitchFamily="34" charset="0"/>
-                <a:ea typeface="Consolas" pitchFamily="34" charset="-122"/>
-                <a:cs typeface="Consolas" pitchFamily="34" charset="-120"/>
-              </a:rPr>
-              <a:t>python pump_status_report.py &lt;path&gt;</a:t>
-            </a:r>
-            <a:endParaRPr lang="en-US" sz="950" dirty="0"/>
-          </a:p>
-        </p:txBody>
-      </p:sp>
-      <p:sp>
-        <p:nvSpPr>
-          <p:cNvPr id="8" name="bullets"/>
-          <p:cNvSpPr txBox="1"/>
-          <p:nvPr/>
-        </p:nvSpPr>
-        <p:spPr>
-          <a:xfrm>
-            <a:off x="640080" y="2560320"/>
-            <a:ext cx="3657600" cy="1463040"/>
-          </a:xfrm>
-          <a:prstGeom prst="rect">
-            <a:avLst/>
-          </a:prstGeom>
-          <a:noFill/>
-          <a:ln/>
-        </p:spPr>
-        <p:txBody>
-          <a:bodyPr wrap="square" lIns="0" tIns="0" rIns="0" bIns="0" rtlCol="0" anchor="t"/>
-          <a:lstStyle/>
-          <a:p>
-            <a:pPr marL="342900" indent="-342900">
-              <a:spcAft>
-                <a:spcPts val="700"/>
-              </a:spcAft>
-              <a:buSzPct val="100000"/>
-              <a:buChar char="•"/>
-            </a:pPr>
-            <a:r>
-              <a:rPr lang="en-US" sz="1300" dirty="0">
-                <a:solidFill>
-                  <a:schemeClr val="tx1"/>
-                </a:solidFill>
-              </a:rPr>
-              <a:t>Writes pump_status_report.txt in the analyzed folder</a:t>
-            </a:r>
-            <a:endParaRPr lang="en-US" sz="1300" dirty="0"/>
-          </a:p>
-          <a:p>
-            <a:pPr marL="342900" indent="-342900">
-              <a:spcAft>
-                <a:spcPts val="700"/>
-              </a:spcAft>
-              <a:buSzPct val="100000"/>
-              <a:buChar char="•"/>
-            </a:pPr>
-            <a:r>
-              <a:rPr lang="en-US" sz="1300" dirty="0">
-                <a:solidFill>
-                  <a:schemeClr val="tx1"/>
-                </a:solidFill>
-              </a:rPr>
-              <a:t>Pump-on files listed shortest to longest</a:t>
-            </a:r>
-            <a:endParaRPr lang="en-US" sz="1300" dirty="0"/>
-          </a:p>
-          <a:p>
-            <a:pPr marL="342900" indent="-342900">
-              <a:spcAft>
-                <a:spcPts val="700"/>
-              </a:spcAft>
-              <a:buSzPct val="100000"/>
-              <a:buChar char="•"/>
-            </a:pPr>
-            <a:r>
-              <a:rPr lang="en-US" sz="1300" dirty="0">
-                <a:solidFill>
-                  <a:schemeClr val="tx1"/>
-                </a:solidFill>
-              </a:rPr>
-              <a:t>Same report in app_pump_status.py</a:t>
-            </a:r>
-            <a:endParaRPr lang="en-US" sz="1300" dirty="0"/>
-          </a:p>
-        </p:txBody>
-      </p:sp>
-      <p:sp>
-        <p:nvSpPr>
-          <p:cNvPr id="9" name="Shape 7"/>
-          <p:cNvSpPr/>
-          <p:nvPr/>
-        </p:nvSpPr>
-        <p:spPr>
-          <a:xfrm>
-            <a:off x="4663440" y="1371600"/>
-            <a:ext cx="4023360" cy="2743200"/>
-          </a:xfrm>
-          <a:prstGeom prst="roundRect">
-            <a:avLst>
-              <a:gd name="adj" fmla="val 3333"/>
-            </a:avLst>
-          </a:prstGeom>
-          <a:solidFill>
-            <a:schemeClr val="bg2"/>
-          </a:solidFill>
-          <a:ln w="12700">
-            <a:solidFill>
-              <a:schemeClr val="bg2"/>
-            </a:solidFill>
-            <a:prstDash val="solid"/>
-          </a:ln>
-        </p:spPr>
-        <p:txBody>
-          <a:bodyPr/>
-          <a:lstStyle/>
-          <a:p>
-            <a:endParaRPr lang="en-US"/>
-          </a:p>
-        </p:txBody>
-      </p:sp>
-      <p:sp>
-        <p:nvSpPr>
-          <p:cNvPr id="10" name="path title 1"/>
-          <p:cNvSpPr txBox="1"/>
-          <p:nvPr/>
-        </p:nvSpPr>
-        <p:spPr>
-          <a:xfrm>
-            <a:off x="4846320" y="1463040"/>
-            <a:ext cx="3657600" cy="365760"/>
-          </a:xfrm>
-          <a:prstGeom prst="rect">
-            <a:avLst/>
-          </a:prstGeom>
-          <a:noFill/>
-          <a:ln/>
-        </p:spPr>
-        <p:txBody>
-          <a:bodyPr wrap="square" lIns="0" tIns="0" rIns="0" bIns="0" rtlCol="0" anchor="ctr"/>
-          <a:lstStyle/>
-          <a:p>
-            <a:pPr marL="0" indent="0">
-              <a:buNone/>
-            </a:pPr>
-            <a:r>
-              <a:rPr lang="en-US" sz="1800" b="1" dirty="0">
-                <a:solidFill>
-                  <a:schemeClr val="accent3"/>
-                </a:solidFill>
-              </a:rPr>
-              <a:t>No pump status</a:t>
-            </a:r>
-            <a:endParaRPr lang="en-US" sz="1800" dirty="0"/>
-          </a:p>
-        </p:txBody>
-      </p:sp>
-      <p:sp>
-        <p:nvSpPr>
-          <p:cNvPr id="11" name="Shape 9"/>
-          <p:cNvSpPr/>
-          <p:nvPr/>
-        </p:nvSpPr>
-        <p:spPr>
-          <a:xfrm>
-            <a:off x="4846320" y="1920240"/>
-            <a:ext cx="3657600" cy="457200"/>
-          </a:xfrm>
-          <a:prstGeom prst="roundRect">
-            <a:avLst>
-              <a:gd name="adj" fmla="val 16000"/>
-            </a:avLst>
-          </a:prstGeom>
-          <a:solidFill>
-            <a:schemeClr val="tx1"/>
-          </a:solidFill>
-          <a:ln w="12700">
-            <a:solidFill>
-              <a:schemeClr val="tx1"/>
-            </a:solidFill>
-            <a:prstDash val="solid"/>
-          </a:ln>
-        </p:spPr>
-        <p:txBody>
-          <a:bodyPr/>
-          <a:lstStyle/>
-          <a:p>
-            <a:endParaRPr lang="en-US"/>
-          </a:p>
-        </p:txBody>
-      </p:sp>
-      <p:sp>
-        <p:nvSpPr>
-          <p:cNvPr id="12" name="command"/>
-          <p:cNvSpPr txBox="1"/>
-          <p:nvPr/>
-        </p:nvSpPr>
-        <p:spPr>
-          <a:xfrm>
-            <a:off x="4956048" y="1920240"/>
-            <a:ext cx="3438144" cy="457200"/>
-          </a:xfrm>
-          <a:prstGeom prst="rect">
-            <a:avLst/>
-          </a:prstGeom>
-          <a:noFill/>
-          <a:ln/>
-        </p:spPr>
-        <p:txBody>
-          <a:bodyPr wrap="square" lIns="0" tIns="0" rIns="0" bIns="0" rtlCol="0" anchor="ctr"/>
-          <a:lstStyle/>
-          <a:p>
-            <a:pPr marL="0" indent="0">
-              <a:buNone/>
-            </a:pPr>
-            <a:r>
-              <a:rPr lang="en-US" sz="950" dirty="0">
-                <a:solidFill>
-                  <a:schemeClr val="bg1"/>
-                </a:solidFill>
-                <a:latin typeface="Consolas" pitchFamily="34" charset="0"/>
-                <a:ea typeface="Consolas" pitchFamily="34" charset="-122"/>
-                <a:cs typeface="Consolas" pitchFamily="34" charset="-120"/>
-              </a:rPr>
-              <a:t>python compare_cnv_lengths.py &lt;cruise_name&gt;</a:t>
-            </a:r>
-            <a:endParaRPr lang="en-US" sz="950" dirty="0"/>
-          </a:p>
-        </p:txBody>
-      </p:sp>
-      <p:sp>
-        <p:nvSpPr>
-          <p:cNvPr id="13" name="bullets"/>
-          <p:cNvSpPr txBox="1"/>
-          <p:nvPr/>
-        </p:nvSpPr>
-        <p:spPr>
-          <a:xfrm>
-            <a:off x="4846320" y="2560320"/>
-            <a:ext cx="3657600" cy="1463040"/>
-          </a:xfrm>
-          <a:prstGeom prst="rect">
-            <a:avLst/>
-          </a:prstGeom>
-          <a:noFill/>
-          <a:ln/>
-        </p:spPr>
-        <p:txBody>
-          <a:bodyPr wrap="square" lIns="0" tIns="0" rIns="0" bIns="0" rtlCol="0" anchor="t"/>
-          <a:lstStyle/>
-          <a:p>
-            <a:pPr marL="342900" indent="-342900">
-              <a:spcAft>
-                <a:spcPts val="700"/>
-              </a:spcAft>
-              <a:buSzPct val="100000"/>
-              <a:buChar char="•"/>
-            </a:pPr>
-            <a:r>
-              <a:rPr lang="en-US" sz="1300" dirty="0">
-                <a:solidFill>
-                  <a:schemeClr val="tx1"/>
-                </a:solidFill>
-              </a:rPr>
-              <a:t>First run the Convert step in UPDOWN (down + upcast)</a:t>
-            </a:r>
-            <a:endParaRPr lang="en-US" sz="1300" dirty="0"/>
-          </a:p>
-          <a:p>
-            <a:pPr marL="342900" indent="-342900">
-              <a:spcAft>
-                <a:spcPts val="700"/>
-              </a:spcAft>
-              <a:buSzPct val="100000"/>
-              <a:buChar char="•"/>
-            </a:pPr>
-            <a:r>
-              <a:rPr lang="en-US" sz="1300" dirty="0">
-                <a:solidFill>
-                  <a:schemeClr val="tx1"/>
-                </a:solidFill>
-              </a:rPr>
-              <a:t>Compares row counts of CNV and UPDOWN files</a:t>
-            </a:r>
-            <a:endParaRPr lang="en-US" sz="1300" dirty="0"/>
-          </a:p>
-          <a:p>
-            <a:pPr marL="342900" indent="-342900">
-              <a:spcAft>
-                <a:spcPts val="700"/>
-              </a:spcAft>
-              <a:buSzPct val="100000"/>
-              <a:buChar char="•"/>
-            </a:pPr>
-            <a:r>
-              <a:rPr lang="en-US" sz="1300" dirty="0">
-                <a:solidFill>
-                  <a:schemeClr val="tx1"/>
-                </a:solidFill>
-              </a:rPr>
-              <a:t>Smallest relative CNV length listed first</a:t>
-            </a:r>
-            <a:endParaRPr lang="en-US" sz="1300" dirty="0"/>
-          </a:p>
-        </p:txBody>
-      </p:sp>
-      <p:sp>
-        <p:nvSpPr>
-          <p:cNvPr id="14" name="next step"/>
-          <p:cNvSpPr txBox="1"/>
-          <p:nvPr/>
-        </p:nvSpPr>
-        <p:spPr>
-          <a:xfrm>
-            <a:off x="457200" y="4251960"/>
-            <a:ext cx="8229600" cy="320040"/>
-          </a:xfrm>
-          <a:prstGeom prst="rect">
-            <a:avLst/>
-          </a:prstGeom>
-          <a:noFill/>
-          <a:ln/>
-        </p:spPr>
-        <p:txBody>
-          <a:bodyPr wrap="square" lIns="0" tIns="0" rIns="0" bIns="0" rtlCol="0" anchor="ctr"/>
-          <a:lstStyle/>
-          <a:p>
-            <a:pPr marL="0" indent="0" algn="ctr">
-              <a:buNone/>
-            </a:pPr>
-            <a:r>
-              <a:rPr lang="en-US" sz="1400" i="1" dirty="0">
-                <a:solidFill>
-                  <a:schemeClr val="accent1"/>
-                </a:solidFill>
-              </a:rPr>
-              <a:t>Then re-convert affected stations in UPDOWN and copy them to CNV</a:t>
-            </a:r>
-            <a:endParaRPr lang="en-US" sz="1400" dirty="0"/>
-          </a:p>
-        </p:txBody>
-      </p:sp>
-      <p:sp>
-        <p:nvSpPr>
-          <p:cNvPr id="25" name="Slide Number Placeholder 0"/>
-          <p:cNvSpPr>
-            <a:spLocks noGrp="1"/>
-          </p:cNvSpPr>
-          <p:nvPr>
-            <p:ph type="sldNum" sz="quarter" idx="4294967295"/>
-          </p:nvPr>
-        </p:nvSpPr>
-        <p:spPr>
-          <a:xfrm>
-            <a:off x="8229600" y="4754880"/>
-            <a:ext cx="457200" cy="274320"/>
-          </a:xfrm>
-          <a:prstGeom prst="rect">
-            <a:avLst/>
-          </a:prstGeom>
-          <a:extLst>
-            <a:ext uri="{C572A759-6A51-4108-AA02-DFA0A04FC94B}">
-              <ma14:wrappingTextBoxFlag xmlns:ma14="http://schemas.microsoft.com/office/mac/drawingml/2011/main" xmlns="" val="0"/>
-            </a:ext>
-          </a:extLst>
-        </p:spPr>
-        <p:txBody>
-          <a:bodyPr/>
-          <a:lstStyle>
-            <a:lvl1pPr>
-              <a:defRPr sz="1000">
-                <a:solidFill>
-                  <a:schemeClr val="accent6"/>
-                </a:solidFill>
-              </a:defRPr>
-            </a:lvl1pPr>
-          </a:lstStyle>
-          <a:p>
-            <a:pPr algn="r"/>
-            <a:fld id="{F7021451-1387-4CA6-816F-3879F97B5CBC}" type="slidenum">
-              <a:rPr lang="en-US" b="0"/>
-              <a:t>5</a:t>
-            </a:fld>
-            <a:endParaRPr lang="en-US"/>
-          </a:p>
-        </p:txBody>
-      </p:sp>
-    </p:spTree>
-  </p:cSld>
-  <p:clrMapOvr>
-    <a:masterClrMapping/>
-  </p:clrMapOvr>
-</p:sld>
-</file>
-
-<file path=ppt/slides/slide6.xml><?xml version="1.0" encoding="utf-8"?>
 <p:sld xmlns:a="http://schemas.openxmlformats.org/drawingml/2006/main" xmlns:r="http://schemas.openxmlformats.org/officeDocument/2006/relationships" xmlns:p="http://schemas.openxmlformats.org/presentationml/2006/main">
   <p:cSld name="Slide 6">
     <p:spTree>
@@ -10080,7 +8697,7 @@
             <a:pPr algn="r"/>
             <a:fld id="{F7021451-1387-4CA6-816F-3879F97B5CBC}" type="slidenum">
               <a:rPr lang="en-US" b="0"/>
-              <a:t>6</a:t>
+              <a:t>5</a:t>
             </a:fld>
             <a:endParaRPr lang="en-US"/>
           </a:p>
@@ -10094,7 +8711,7 @@
 </p:sld>
 </file>
 
-<file path=ppt/slides/slide7.xml><?xml version="1.0" encoding="utf-8"?>
+<file path=ppt/slides/slide6.xml><?xml version="1.0" encoding="utf-8"?>
 <p:sld xmlns:a="http://schemas.openxmlformats.org/drawingml/2006/main" xmlns:r="http://schemas.openxmlformats.org/officeDocument/2006/relationships" xmlns:p="http://schemas.openxmlformats.org/presentationml/2006/main">
   <p:cSld name="Slide 7">
     <p:spTree>
@@ -10448,7 +9065,7 @@
             <a:pPr algn="r"/>
             <a:fld id="{F7021451-1387-4CA6-816F-3879F97B5CBC}" type="slidenum">
               <a:rPr lang="en-US" b="0"/>
-              <a:t>7</a:t>
+              <a:t>6</a:t>
             </a:fld>
             <a:endParaRPr lang="en-US"/>
           </a:p>
@@ -10462,7 +9079,7 @@
 </p:sld>
 </file>
 
-<file path=ppt/slides/slide8.xml><?xml version="1.0" encoding="utf-8"?>
+<file path=ppt/slides/slide7.xml><?xml version="1.0" encoding="utf-8"?>
 <p:sld xmlns:a="http://schemas.openxmlformats.org/drawingml/2006/main" xmlns:r="http://schemas.openxmlformats.org/officeDocument/2006/relationships" xmlns:p="http://schemas.openxmlformats.org/presentationml/2006/main">
   <p:cSld name="Slide 8">
     <p:spTree>
@@ -10889,7 +9506,7 @@
             <a:pPr algn="r"/>
             <a:fld id="{F7021451-1387-4CA6-816F-3879F97B5CBC}" type="slidenum">
               <a:rPr lang="en-US" b="0"/>
-              <a:t>8</a:t>
+              <a:t>7</a:t>
             </a:fld>
             <a:endParaRPr lang="en-US"/>
           </a:p>
@@ -10903,7 +9520,7 @@
 </p:sld>
 </file>
 
-<file path=ppt/slides/slide9.xml><?xml version="1.0" encoding="utf-8"?>
+<file path=ppt/slides/slide8.xml><?xml version="1.0" encoding="utf-8"?>
 <p:sld xmlns:a="http://schemas.openxmlformats.org/drawingml/2006/main" xmlns:r="http://schemas.openxmlformats.org/officeDocument/2006/relationships" xmlns:p="http://schemas.openxmlformats.org/presentationml/2006/main">
   <p:cSld name="Slide 9">
     <p:spTree>
@@ -11263,6 +9880,374 @@
       <p:sp>
         <p:nvSpPr>
           <p:cNvPr id="10" name="source note"/>
+          <p:cNvSpPr txBox="1"/>
+          <p:nvPr/>
+        </p:nvSpPr>
+        <p:spPr>
+          <a:xfrm>
+            <a:off x="3474720" y="4754880"/>
+            <a:ext cx="4663440" cy="274320"/>
+          </a:xfrm>
+          <a:prstGeom prst="rect">
+            <a:avLst/>
+          </a:prstGeom>
+          <a:noFill/>
+          <a:ln/>
+        </p:spPr>
+        <p:txBody>
+          <a:bodyPr wrap="square" lIns="0" tIns="0" rIns="0" bIns="0" rtlCol="0" anchor="ctr"/>
+          <a:lstStyle/>
+          <a:p>
+            <a:pPr marL="0" indent="0" algn="r">
+              <a:buNone/>
+            </a:pPr>
+            <a:r>
+              <a:rPr lang="en-US" sz="900" dirty="0">
+                <a:solidFill>
+                  <a:schemeClr val="accent6"/>
+                </a:solidFill>
+              </a:rPr>
+              <a:t>Figure: Sea-Bird Scientific, SBE Data Processing training, Module 9</a:t>
+            </a:r>
+            <a:endParaRPr lang="en-US" sz="900" dirty="0"/>
+          </a:p>
+        </p:txBody>
+      </p:sp>
+      <p:sp>
+        <p:nvSpPr>
+          <p:cNvPr id="25" name="Slide Number Placeholder 0"/>
+          <p:cNvSpPr>
+            <a:spLocks noGrp="1"/>
+          </p:cNvSpPr>
+          <p:nvPr>
+            <p:ph type="sldNum" sz="quarter" idx="4294967295"/>
+          </p:nvPr>
+        </p:nvSpPr>
+        <p:spPr>
+          <a:xfrm>
+            <a:off x="8229600" y="4754880"/>
+            <a:ext cx="457200" cy="274320"/>
+          </a:xfrm>
+          <a:prstGeom prst="rect">
+            <a:avLst/>
+          </a:prstGeom>
+          <a:extLst>
+            <a:ext uri="{C572A759-6A51-4108-AA02-DFA0A04FC94B}">
+              <ma14:wrappingTextBoxFlag xmlns:ma14="http://schemas.microsoft.com/office/mac/drawingml/2011/main" xmlns="" val="0"/>
+            </a:ext>
+          </a:extLst>
+        </p:spPr>
+        <p:txBody>
+          <a:bodyPr/>
+          <a:lstStyle>
+            <a:lvl1pPr>
+              <a:defRPr sz="1000">
+                <a:solidFill>
+                  <a:schemeClr val="accent6"/>
+                </a:solidFill>
+              </a:defRPr>
+            </a:lvl1pPr>
+          </a:lstStyle>
+          <a:p>
+            <a:pPr algn="r"/>
+            <a:fld id="{F7021451-1387-4CA6-816F-3879F97B5CBC}" type="slidenum">
+              <a:rPr lang="en-US" b="0"/>
+              <a:t>8</a:t>
+            </a:fld>
+            <a:endParaRPr lang="en-US"/>
+          </a:p>
+        </p:txBody>
+      </p:sp>
+    </p:spTree>
+  </p:cSld>
+  <p:clrMapOvr>
+    <a:masterClrMapping/>
+  </p:clrMapOvr>
+</p:sld>
+</file>
+
+<file path=ppt/slides/slide9.xml><?xml version="1.0" encoding="utf-8"?>
+<p:sld xmlns:a="http://schemas.openxmlformats.org/drawingml/2006/main" xmlns:r="http://schemas.openxmlformats.org/officeDocument/2006/relationships" xmlns:p="http://schemas.openxmlformats.org/presentationml/2006/main">
+  <p:cSld name="Slide 10">
+    <p:spTree>
+      <p:nvGrpSpPr>
+        <p:cNvPr id="1" name=""/>
+        <p:cNvGrpSpPr/>
+        <p:nvPr/>
+      </p:nvGrpSpPr>
+      <p:grpSpPr>
+        <a:xfrm>
+          <a:off x="0" y="0"/>
+          <a:ext cx="0" cy="0"/>
+          <a:chOff x="0" y="0"/>
+          <a:chExt cx="0" cy="0"/>
+        </a:xfrm>
+      </p:grpSpPr>
+      <p:sp>
+        <p:nvSpPr>
+          <p:cNvPr id="2" name="Text 0"/>
+          <p:cNvSpPr>
+            <a:spLocks noGrp="1"/>
+          </p:cNvSpPr>
+          <p:nvPr>
+            <p:ph type="title" idx="100" hasCustomPrompt="1"/>
+          </p:nvPr>
+        </p:nvSpPr>
+        <p:spPr>
+          <a:xfrm>
+            <a:off x="457200" y="274320"/>
+            <a:ext cx="8229600" cy="594360"/>
+          </a:xfrm>
+          <a:prstGeom prst="rect">
+            <a:avLst/>
+          </a:prstGeom>
+          <a:noFill/>
+          <a:ln/>
+        </p:spPr>
+        <p:txBody>
+          <a:bodyPr wrap="square" lIns="0" tIns="0" rIns="0" bIns="0" rtlCol="0" anchor="ctr"/>
+          <a:lstStyle/>
+          <a:p>
+            <a:pPr marL="0" indent="0" algn="l">
+              <a:buNone/>
+            </a:pPr>
+            <a:r>
+              <a:rPr lang="en-US" sz="3200" b="1" dirty="0">
+                <a:solidFill>
+                  <a:schemeClr val="tx1"/>
+                </a:solidFill>
+              </a:rPr>
+              <a:t>Hysteresis or a Real Feature?</a:t>
+            </a:r>
+            <a:endParaRPr lang="en-US" sz="3200" dirty="0"/>
+          </a:p>
+        </p:txBody>
+      </p:sp>
+      <p:sp>
+        <p:nvSpPr>
+          <p:cNvPr id="3" name="tagline"/>
+          <p:cNvSpPr txBox="1"/>
+          <p:nvPr/>
+        </p:nvSpPr>
+        <p:spPr>
+          <a:xfrm>
+            <a:off x="457200" y="896112"/>
+            <a:ext cx="8229600" cy="292608"/>
+          </a:xfrm>
+          <a:prstGeom prst="rect">
+            <a:avLst/>
+          </a:prstGeom>
+          <a:noFill/>
+          <a:ln/>
+        </p:spPr>
+        <p:txBody>
+          <a:bodyPr wrap="square" lIns="0" tIns="0" rIns="0" bIns="0" rtlCol="0" anchor="ctr"/>
+          <a:lstStyle/>
+          <a:p>
+            <a:pPr marL="0" indent="0">
+              <a:buNone/>
+            </a:pPr>
+            <a:r>
+              <a:rPr lang="en-US" sz="1500" i="1" dirty="0">
+                <a:solidFill>
+                  <a:schemeClr val="accent1"/>
+                </a:solidFill>
+              </a:rPr>
+              <a:t>Check before you shift the oxygen data</a:t>
+            </a:r>
+            <a:endParaRPr lang="en-US" sz="1500" dirty="0"/>
+          </a:p>
+        </p:txBody>
+      </p:sp>
+      <p:sp>
+        <p:nvSpPr>
+          <p:cNvPr id="4" name="bullets"/>
+          <p:cNvSpPr txBox="1"/>
+          <p:nvPr/>
+        </p:nvSpPr>
+        <p:spPr>
+          <a:xfrm>
+            <a:off x="457200" y="1417320"/>
+            <a:ext cx="3840480" cy="3108960"/>
+          </a:xfrm>
+          <a:prstGeom prst="rect">
+            <a:avLst/>
+          </a:prstGeom>
+          <a:noFill/>
+          <a:ln/>
+        </p:spPr>
+        <p:txBody>
+          <a:bodyPr wrap="square" lIns="0" tIns="0" rIns="0" bIns="0" rtlCol="0" anchor="t"/>
+          <a:lstStyle/>
+          <a:p>
+            <a:pPr marL="342900" indent="-342900">
+              <a:spcAft>
+                <a:spcPts val="700"/>
+              </a:spcAft>
+              <a:buSzPct val="100000"/>
+              <a:buChar char="•"/>
+            </a:pPr>
+            <a:r>
+              <a:rPr lang="en-US" sz="1300" dirty="0">
+                <a:solidFill>
+                  <a:schemeClr val="tx1"/>
+                </a:solidFill>
+              </a:rPr>
+              <a:t>Hysteresis is easy to see in pressure vs oxygen profiles</a:t>
+            </a:r>
+            <a:endParaRPr lang="en-US" sz="1300" dirty="0"/>
+          </a:p>
+          <a:p>
+            <a:pPr marL="342900" indent="-342900">
+              <a:spcAft>
+                <a:spcPts val="700"/>
+              </a:spcAft>
+              <a:buSzPct val="100000"/>
+              <a:buChar char="•"/>
+            </a:pPr>
+            <a:r>
+              <a:rPr lang="en-US" sz="1300" dirty="0">
+                <a:solidFill>
+                  <a:schemeClr val="tx1"/>
+                </a:solidFill>
+              </a:rPr>
+              <a:t>But real ocean features can look the same: a drifting ship near the Gulf Stream sampled a feature at different depths on down and upcast</a:t>
+            </a:r>
+            <a:endParaRPr lang="en-US" sz="1300" dirty="0"/>
+          </a:p>
+          <a:p>
+            <a:pPr marL="342900" indent="-342900">
+              <a:spcAft>
+                <a:spcPts val="700"/>
+              </a:spcAft>
+              <a:buSzPct val="100000"/>
+              <a:buChar char="•"/>
+            </a:pPr>
+            <a:r>
+              <a:rPr lang="en-US" sz="1300" dirty="0">
+                <a:solidFill>
+                  <a:schemeClr val="tx1"/>
+                </a:solidFill>
+              </a:rPr>
+              <a:t>Plot oxygen vs temperature to tell the two apart</a:t>
+            </a:r>
+            <a:endParaRPr lang="en-US" sz="1300" dirty="0"/>
+          </a:p>
+          <a:p>
+            <a:pPr marL="342900" indent="-342900">
+              <a:spcAft>
+                <a:spcPts val="700"/>
+              </a:spcAft>
+              <a:buSzPct val="100000"/>
+              <a:buChar char="•"/>
+            </a:pPr>
+            <a:r>
+              <a:rPr lang="en-US" sz="1300" dirty="0">
+                <a:solidFill>
+                  <a:schemeClr val="tx1"/>
+                </a:solidFill>
+              </a:rPr>
+              <a:t>Hydrographic phenomena should not be removed by data manipulation</a:t>
+            </a:r>
+            <a:endParaRPr lang="en-US" sz="1300" dirty="0"/>
+          </a:p>
+        </p:txBody>
+      </p:sp>
+      <p:sp>
+        <p:nvSpPr>
+          <p:cNvPr id="5" name="Oxygen vs temperature frame"/>
+          <p:cNvSpPr/>
+          <p:nvPr/>
+        </p:nvSpPr>
+        <p:spPr>
+          <a:xfrm>
+            <a:off x="4507992" y="1828441"/>
+            <a:ext cx="4197096" cy="1738077"/>
+          </a:xfrm>
+          <a:prstGeom prst="rect">
+            <a:avLst/>
+          </a:prstGeom>
+          <a:solidFill>
+            <a:schemeClr val="bg1"/>
+          </a:solidFill>
+          <a:ln w="9525">
+            <a:solidFill>
+              <a:schemeClr val="accent5"/>
+            </a:solidFill>
+            <a:prstDash val="solid"/>
+          </a:ln>
+        </p:spPr>
+        <p:txBody>
+          <a:bodyPr/>
+          <a:lstStyle/>
+          <a:p>
+            <a:endParaRPr lang="en-US"/>
+          </a:p>
+        </p:txBody>
+      </p:sp>
+      <p:pic>
+        <p:nvPicPr>
+          <p:cNvPr id="6" name="Oxygen vs temperature" descr="Oxygen vs temperature"/>
+          <p:cNvPicPr>
+            <a:picLocks noChangeAspect="1"/>
+          </p:cNvPicPr>
+          <p:nvPr/>
+        </p:nvPicPr>
+        <p:blipFill>
+          <a:blip r:embed="rId3"/>
+          <a:stretch>
+            <a:fillRect/>
+          </a:stretch>
+        </p:blipFill>
+        <p:spPr>
+          <a:xfrm>
+            <a:off x="4526280" y="1846729"/>
+            <a:ext cx="4160520" cy="1701501"/>
+          </a:xfrm>
+          <a:prstGeom prst="rect">
+            <a:avLst/>
+          </a:prstGeom>
+        </p:spPr>
+      </p:pic>
+      <p:sp>
+        <p:nvSpPr>
+          <p:cNvPr id="7" name="caption"/>
+          <p:cNvSpPr txBox="1"/>
+          <p:nvPr/>
+        </p:nvSpPr>
+        <p:spPr>
+          <a:xfrm>
+            <a:off x="4526280" y="3603095"/>
+            <a:ext cx="4160520" cy="274320"/>
+          </a:xfrm>
+          <a:prstGeom prst="rect">
+            <a:avLst/>
+          </a:prstGeom>
+          <a:noFill/>
+          <a:ln/>
+        </p:spPr>
+        <p:txBody>
+          <a:bodyPr wrap="square" lIns="0" tIns="0" rIns="0" bIns="0" rtlCol="0" anchor="ctr"/>
+          <a:lstStyle/>
+          <a:p>
+            <a:pPr marL="0" indent="0" algn="ctr">
+              <a:buNone/>
+            </a:pPr>
+            <a:r>
+              <a:rPr lang="en-US" sz="1100" i="1" dirty="0">
+                <a:solidFill>
+                  <a:schemeClr val="accent6"/>
+                </a:solidFill>
+              </a:rPr>
+              <a:t>Oxygen vs temperature plots for two casts</a:t>
+            </a:r>
+            <a:endParaRPr lang="en-US" sz="1100" dirty="0"/>
+          </a:p>
+        </p:txBody>
+      </p:sp>
+      <p:sp>
+        <p:nvSpPr>
+          <p:cNvPr id="8" name="source note"/>
           <p:cNvSpPr txBox="1"/>
           <p:nvPr/>
         </p:nvSpPr>

</xml_diff>